<commit_message>
sd-07-017: Apple keeps parts of the card number and DAN, not the full numbers
Co-Authored-By: Claude Opus 5.5 <noreply@anthropic.com>
Claude-Session: https://claude.ai/code/session_01TDEQZkTojRsEuCWxmNaEbL
</commit_message>
<xml_diff>
--- a/system-design-101/vi/lessons/sd-07-017/slides/sd-07-017.pptx
+++ b/system-design-101/vi/lessons/sd-07-017/slides/sd-07-017.pptx
@@ -5409,10 +5409,10 @@
                 <a:ea typeface="Bricolage Grotesque ExtraBold" pitchFamily="34" charset="-122"/>
                 <a:cs typeface="Bricolage Grotesque ExtraBold" pitchFamily="34" charset="-120"/>
               </a:rPr>
-              <a:t> không</a:t>
-            </a:r>
-            <a:r>
-              <a:rPr lang="en-US" sz="6900" dirty="0" spc="1" kern="0">
+              <a:t> không giữ</a:t>
+            </a:r>
+            <a:r>
+              <a:rPr lang="en-US" sz="6900" dirty="0" spc="2" kern="0">
                 <a:solidFill>
                   <a:srgbClr val="F3EEE3"/>
                 </a:solidFill>
@@ -5420,7 +5420,7 @@
                 <a:ea typeface="Bricolage Grotesque ExtraBold" pitchFamily="34" charset="-122"/>
                 <a:cs typeface="Bricolage Grotesque ExtraBold" pitchFamily="34" charset="-120"/>
               </a:rPr>
-              <a:t> lưu</a:t>
+              <a:t> số</a:t>
             </a:r>
             <a:r>
               <a:rPr lang="en-US" sz="6900" dirty="0" spc="3" kern="0">
@@ -5432,6 +5432,28 @@
                 <a:cs typeface="Bricolage Grotesque ExtraBold" pitchFamily="34" charset="-120"/>
               </a:rPr>
               <a:t> thẻ</a:t>
+            </a:r>
+            <a:r>
+              <a:rPr lang="en-US" sz="6900" dirty="0" spc="6" kern="0">
+                <a:solidFill>
+                  <a:srgbClr val="F3EEE3"/>
+                </a:solidFill>
+                <a:latin typeface="Bricolage Grotesque ExtraBold" pitchFamily="34" charset="0"/>
+                <a:ea typeface="Bricolage Grotesque ExtraBold" pitchFamily="34" charset="-122"/>
+                <a:cs typeface="Bricolage Grotesque ExtraBold" pitchFamily="34" charset="-120"/>
+              </a:rPr>
+              <a:t> đầy</a:t>
+            </a:r>
+            <a:r>
+              <a:rPr lang="en-US" sz="6900" dirty="0" spc="19" kern="0">
+                <a:solidFill>
+                  <a:srgbClr val="F3EEE3"/>
+                </a:solidFill>
+                <a:latin typeface="Bricolage Grotesque ExtraBold" pitchFamily="34" charset="0"/>
+                <a:ea typeface="Bricolage Grotesque ExtraBold" pitchFamily="34" charset="-122"/>
+                <a:cs typeface="Bricolage Grotesque ExtraBold" pitchFamily="34" charset="-120"/>
+              </a:rPr>
+              <a:t> đủ</a:t>
             </a:r>
             <a:endParaRPr lang="en-US" sz="6900" dirty="0"/>
           </a:p>

</xml_diff>